<commit_message>
Estiliza o campo de arquivo no tema escuro e conclui o QA visual dos tutoriais
Sistema:
- O botão nativo do campo de arquivo ficava branco sobre branco no tema
  escuro (ilegível em "Escolher arquivo" no envio de materiais e de vídeos).
  Agora usa a cor de destaque com texto escuro, via ::file-selector-button
  (com fallback para WebKit antigo).

Tutoriais (PPTX): corrigidos os 6 defeitos severos da segunda revisão visual
- tela "Precisa de ajuda?" com 4 cartões: o rodapé invadia o último cartão
- capturas do cadastro de usuários e da recusa com relatório reposicionadas
  em faixa horizontal, agora legíveis no tamanho do slide
- recortes do menu Admin e da janela de recusa refeitos sem elementos
  cortados ao meio

Co-Authored-By: Claude Opus 5 <noreply@anthropic.com>
Claude-Session: https://claude.ai/code/session_01Ex7zLTfe8D6LjJDCma6BhQ
</commit_message>
<xml_diff>
--- a/docs/tutoriais/Tutorial-Admin.pptx
+++ b/docs/tutoriais/Tutorial-Admin.pptx
@@ -3718,12 +3718,12 @@
         </p:nvSpPr>
         <p:spPr>
           <a:xfrm>
-            <a:off x="640080" y="1691640"/>
-            <a:ext cx="10881360" cy="1024128"/>
+            <a:off x="640080" y="1645920"/>
+            <a:ext cx="10881360" cy="914400"/>
           </a:xfrm>
           <a:prstGeom prst="roundRect">
             <a:avLst>
-              <a:gd name="adj" fmla="val 8036"/>
+              <a:gd name="adj" fmla="val 9000"/>
             </a:avLst>
           </a:prstGeom>
           <a:solidFill>
@@ -3745,7 +3745,7 @@
         </p:nvSpPr>
         <p:spPr>
           <a:xfrm>
-            <a:off x="841248" y="1837944"/>
+            <a:off x="841248" y="1792224"/>
             <a:ext cx="10479024" cy="329184"/>
           </a:xfrm>
           <a:prstGeom prst="rect">
@@ -3784,8 +3784,8 @@
         </p:nvSpPr>
         <p:spPr>
           <a:xfrm>
-            <a:off x="841248" y="2167128"/>
-            <a:ext cx="10479024" cy="420624"/>
+            <a:off x="841248" y="2121408"/>
+            <a:ext cx="10479024" cy="310896"/>
           </a:xfrm>
           <a:prstGeom prst="rect">
             <a:avLst/>
@@ -3804,7 +3804,7 @@
               <a:buNone/>
             </a:pPr>
             <a:r>
-              <a:rPr lang="en-US" sz="1300" dirty="0">
+              <a:rPr lang="en-US" sz="1250" dirty="0">
                 <a:solidFill>
                   <a:srgbClr val="E8EEF7"/>
                 </a:solidFill>
@@ -3814,7 +3814,7 @@
               </a:rPr>
               <a:t>Antes de qualquer migração (database/upgrade_v*.sql): cPanel → phpMyAdmin → Exportar.</a:t>
             </a:r>
-            <a:endParaRPr lang="en-US" sz="1300" dirty="0"/>
+            <a:endParaRPr lang="en-US" sz="1250" dirty="0"/>
           </a:p>
         </p:txBody>
       </p:sp>
@@ -3826,12 +3826,12 @@
         </p:nvSpPr>
         <p:spPr>
           <a:xfrm>
-            <a:off x="640080" y="2862072"/>
-            <a:ext cx="10881360" cy="1024128"/>
+            <a:off x="640080" y="2679192"/>
+            <a:ext cx="10881360" cy="914400"/>
           </a:xfrm>
           <a:prstGeom prst="roundRect">
             <a:avLst>
-              <a:gd name="adj" fmla="val 8036"/>
+              <a:gd name="adj" fmla="val 9000"/>
             </a:avLst>
           </a:prstGeom>
           <a:solidFill>
@@ -3853,7 +3853,7 @@
         </p:nvSpPr>
         <p:spPr>
           <a:xfrm>
-            <a:off x="841248" y="3008376"/>
+            <a:off x="841248" y="2825496"/>
             <a:ext cx="10479024" cy="329184"/>
           </a:xfrm>
           <a:prstGeom prst="rect">
@@ -3892,8 +3892,8 @@
         </p:nvSpPr>
         <p:spPr>
           <a:xfrm>
-            <a:off x="841248" y="3337560"/>
-            <a:ext cx="10479024" cy="420624"/>
+            <a:off x="841248" y="3154680"/>
+            <a:ext cx="10479024" cy="310896"/>
           </a:xfrm>
           <a:prstGeom prst="rect">
             <a:avLst/>
@@ -3912,7 +3912,7 @@
               <a:buNone/>
             </a:pPr>
             <a:r>
-              <a:rPr lang="en-US" sz="1300" dirty="0">
+              <a:rPr lang="en-US" sz="1250" dirty="0">
                 <a:solidFill>
                   <a:srgbClr val="E8EEF7"/>
                 </a:solidFill>
@@ -3922,7 +3922,7 @@
               </a:rPr>
               <a:t>Troque a senha do usuário inicial admin@scseduca.com.br no primeiro acesso.</a:t>
             </a:r>
-            <a:endParaRPr lang="en-US" sz="1300" dirty="0"/>
+            <a:endParaRPr lang="en-US" sz="1250" dirty="0"/>
           </a:p>
         </p:txBody>
       </p:sp>
@@ -3934,12 +3934,12 @@
         </p:nvSpPr>
         <p:spPr>
           <a:xfrm>
-            <a:off x="640080" y="4032504"/>
-            <a:ext cx="10881360" cy="1024128"/>
+            <a:off x="640080" y="3712464"/>
+            <a:ext cx="10881360" cy="914400"/>
           </a:xfrm>
           <a:prstGeom prst="roundRect">
             <a:avLst>
-              <a:gd name="adj" fmla="val 8036"/>
+              <a:gd name="adj" fmla="val 9000"/>
             </a:avLst>
           </a:prstGeom>
           <a:solidFill>
@@ -3961,7 +3961,7 @@
         </p:nvSpPr>
         <p:spPr>
           <a:xfrm>
-            <a:off x="841248" y="4178808"/>
+            <a:off x="841248" y="3858768"/>
             <a:ext cx="10479024" cy="329184"/>
           </a:xfrm>
           <a:prstGeom prst="rect">
@@ -4000,8 +4000,8 @@
         </p:nvSpPr>
         <p:spPr>
           <a:xfrm>
-            <a:off x="841248" y="4507992"/>
-            <a:ext cx="10479024" cy="420624"/>
+            <a:off x="841248" y="4187952"/>
+            <a:ext cx="10479024" cy="310896"/>
           </a:xfrm>
           <a:prstGeom prst="rect">
             <a:avLst/>
@@ -4020,7 +4020,7 @@
               <a:buNone/>
             </a:pPr>
             <a:r>
-              <a:rPr lang="en-US" sz="1300" dirty="0">
+              <a:rPr lang="en-US" sz="1250" dirty="0">
                 <a:solidFill>
                   <a:srgbClr val="E8EEF7"/>
                 </a:solidFill>
@@ -4030,7 +4030,7 @@
               </a:rPr>
               <a:t>Colunas, status e transições mudam NA HORA para todos.</a:t>
             </a:r>
-            <a:endParaRPr lang="en-US" sz="1300" dirty="0"/>
+            <a:endParaRPr lang="en-US" sz="1250" dirty="0"/>
           </a:p>
         </p:txBody>
       </p:sp>
@@ -4042,12 +4042,12 @@
         </p:nvSpPr>
         <p:spPr>
           <a:xfrm>
-            <a:off x="640080" y="5202936"/>
-            <a:ext cx="10881360" cy="1024128"/>
+            <a:off x="640080" y="4745736"/>
+            <a:ext cx="10881360" cy="914400"/>
           </a:xfrm>
           <a:prstGeom prst="roundRect">
             <a:avLst>
-              <a:gd name="adj" fmla="val 8036"/>
+              <a:gd name="adj" fmla="val 9000"/>
             </a:avLst>
           </a:prstGeom>
           <a:solidFill>
@@ -4069,7 +4069,7 @@
         </p:nvSpPr>
         <p:spPr>
           <a:xfrm>
-            <a:off x="841248" y="5349240"/>
+            <a:off x="841248" y="4892040"/>
             <a:ext cx="10479024" cy="329184"/>
           </a:xfrm>
           <a:prstGeom prst="rect">
@@ -4108,8 +4108,8 @@
         </p:nvSpPr>
         <p:spPr>
           <a:xfrm>
-            <a:off x="841248" y="5678424"/>
-            <a:ext cx="10479024" cy="420624"/>
+            <a:off x="841248" y="5221224"/>
+            <a:ext cx="10479024" cy="310896"/>
           </a:xfrm>
           <a:prstGeom prst="rect">
             <a:avLst/>
@@ -4128,7 +4128,7 @@
               <a:buNone/>
             </a:pPr>
             <a:r>
-              <a:rPr lang="en-US" sz="1300" dirty="0">
+              <a:rPr lang="en-US" sz="1250" dirty="0">
                 <a:solidFill>
                   <a:srgbClr val="E8EEF7"/>
                 </a:solidFill>
@@ -4138,7 +4138,7 @@
               </a:rPr>
               <a:t>Olhe a Auditoria e a fila de Notificações — erros de e-mail aparecem lá primeiro.</a:t>
             </a:r>
-            <a:endParaRPr lang="en-US" sz="1300" dirty="0"/>
+            <a:endParaRPr lang="en-US" sz="1250" dirty="0"/>
           </a:p>
         </p:txBody>
       </p:sp>
@@ -4150,24 +4150,24 @@
         </p:nvSpPr>
         <p:spPr>
           <a:xfrm>
-            <a:off x="640080" y="5943600"/>
-            <a:ext cx="10058400" cy="365760"/>
-          </a:xfrm>
-          <a:prstGeom prst="rect">
-            <a:avLst/>
-          </a:prstGeom>
-          <a:noFill/>
-          <a:ln/>
-        </p:spPr>
-        <p:txBody>
-          <a:bodyPr wrap="square" lIns="0" tIns="0" rIns="0" bIns="0" rtlCol="0" anchor="ctr"/>
-          <a:lstStyle/>
-          <a:p>
-            <a:pPr indent="0" marL="0">
-              <a:buNone/>
-            </a:pPr>
-            <a:r>
-              <a:rPr lang="en-US" sz="1600" dirty="0">
+            <a:off x="640080" y="5989320"/>
+            <a:ext cx="10058400" cy="347472"/>
+          </a:xfrm>
+          <a:prstGeom prst="rect">
+            <a:avLst/>
+          </a:prstGeom>
+          <a:noFill/>
+          <a:ln/>
+        </p:spPr>
+        <p:txBody>
+          <a:bodyPr wrap="square" lIns="0" tIns="0" rIns="0" bIns="0" rtlCol="0" anchor="ctr"/>
+          <a:lstStyle/>
+          <a:p>
+            <a:pPr indent="0" marL="0">
+              <a:buNone/>
+            </a:pPr>
+            <a:r>
+              <a:rPr lang="en-US" sz="1500" dirty="0">
                 <a:solidFill>
                   <a:srgbClr val="8BAAC8"/>
                 </a:solidFill>
@@ -4181,7 +4181,7 @@
               <a:buNone/>
             </a:pPr>
             <a:r>
-              <a:rPr lang="en-US" sz="1600" b="1" dirty="0">
+              <a:rPr lang="en-US" sz="1500" b="1" dirty="0">
                 <a:solidFill>
                   <a:srgbClr val="22D3EE"/>
                 </a:solidFill>
@@ -4191,7 +4191,7 @@
               </a:rPr>
               <a:t>ti.cecape@scseduca.com.br</a:t>
             </a:r>
-            <a:endParaRPr lang="en-US" sz="1600" dirty="0"/>
+            <a:endParaRPr lang="en-US" sz="1500" dirty="0"/>
           </a:p>
         </p:txBody>
       </p:sp>
@@ -5403,12 +5403,12 @@
         </p:nvSpPr>
         <p:spPr>
           <a:xfrm>
-            <a:off x="839677" y="1554480"/>
-            <a:ext cx="2344006" cy="4480560"/>
+            <a:off x="726229" y="1554480"/>
+            <a:ext cx="2570901" cy="4480560"/>
           </a:xfrm>
           <a:prstGeom prst="roundRect">
             <a:avLst>
-              <a:gd name="adj" fmla="val 3511"/>
+              <a:gd name="adj" fmla="val 3201"/>
             </a:avLst>
           </a:prstGeom>
           <a:solidFill>
@@ -5438,8 +5438,8 @@
         </p:blipFill>
         <p:spPr>
           <a:xfrm>
-            <a:off x="949405" y="1664208"/>
-            <a:ext cx="2124550" cy="4261104"/>
+            <a:off x="835957" y="1664208"/>
+            <a:ext cx="2351445" cy="4261104"/>
           </a:xfrm>
           <a:prstGeom prst="rect">
             <a:avLst/>
@@ -7178,7 +7178,7 @@
         <p:spPr>
           <a:xfrm>
             <a:off x="1097280" y="1737360"/>
-            <a:ext cx="5212080" cy="713232"/>
+            <a:ext cx="5212080" cy="484632"/>
           </a:xfrm>
           <a:prstGeom prst="rect">
             <a:avLst/>
@@ -7230,7 +7230,7 @@
         </p:nvSpPr>
         <p:spPr>
           <a:xfrm>
-            <a:off x="640080" y="2496312"/>
+            <a:off x="640080" y="2267712"/>
             <a:ext cx="310896" cy="310896"/>
           </a:xfrm>
           <a:prstGeom prst="ellipse">
@@ -7250,7 +7250,7 @@
         </p:nvSpPr>
         <p:spPr>
           <a:xfrm>
-            <a:off x="640080" y="2496312"/>
+            <a:off x="640080" y="2267712"/>
             <a:ext cx="310896" cy="310896"/>
           </a:xfrm>
           <a:prstGeom prst="rect">
@@ -7289,8 +7289,8 @@
         </p:nvSpPr>
         <p:spPr>
           <a:xfrm>
-            <a:off x="1097280" y="2450592"/>
-            <a:ext cx="5212080" cy="713232"/>
+            <a:off x="1097280" y="2221992"/>
+            <a:ext cx="5212080" cy="484632"/>
           </a:xfrm>
           <a:prstGeom prst="rect">
             <a:avLst/>
@@ -7342,7 +7342,7 @@
         </p:nvSpPr>
         <p:spPr>
           <a:xfrm>
-            <a:off x="640080" y="3209544"/>
+            <a:off x="640080" y="2752344"/>
             <a:ext cx="310896" cy="310896"/>
           </a:xfrm>
           <a:prstGeom prst="ellipse">
@@ -7362,7 +7362,7 @@
         </p:nvSpPr>
         <p:spPr>
           <a:xfrm>
-            <a:off x="640080" y="3209544"/>
+            <a:off x="640080" y="2752344"/>
             <a:ext cx="310896" cy="310896"/>
           </a:xfrm>
           <a:prstGeom prst="rect">
@@ -7401,8 +7401,8 @@
         </p:nvSpPr>
         <p:spPr>
           <a:xfrm>
-            <a:off x="1097280" y="3163824"/>
-            <a:ext cx="5212080" cy="713232"/>
+            <a:off x="1097280" y="2706624"/>
+            <a:ext cx="5212080" cy="484632"/>
           </a:xfrm>
           <a:prstGeom prst="rect">
             <a:avLst/>
@@ -7454,7 +7454,7 @@
         </p:nvSpPr>
         <p:spPr>
           <a:xfrm>
-            <a:off x="640080" y="3922776"/>
+            <a:off x="640080" y="3236976"/>
             <a:ext cx="310896" cy="310896"/>
           </a:xfrm>
           <a:prstGeom prst="ellipse">
@@ -7474,7 +7474,7 @@
         </p:nvSpPr>
         <p:spPr>
           <a:xfrm>
-            <a:off x="640080" y="3922776"/>
+            <a:off x="640080" y="3236976"/>
             <a:ext cx="310896" cy="310896"/>
           </a:xfrm>
           <a:prstGeom prst="rect">
@@ -7513,8 +7513,8 @@
         </p:nvSpPr>
         <p:spPr>
           <a:xfrm>
-            <a:off x="1097280" y="3877056"/>
-            <a:ext cx="5212080" cy="713232"/>
+            <a:off x="1097280" y="3191256"/>
+            <a:ext cx="5212080" cy="484632"/>
           </a:xfrm>
           <a:prstGeom prst="rect">
             <a:avLst/>
@@ -7566,7 +7566,7 @@
         </p:nvSpPr>
         <p:spPr>
           <a:xfrm>
-            <a:off x="640080" y="4636008"/>
+            <a:off x="640080" y="3721608"/>
             <a:ext cx="310896" cy="310896"/>
           </a:xfrm>
           <a:prstGeom prst="ellipse">
@@ -7586,7 +7586,7 @@
         </p:nvSpPr>
         <p:spPr>
           <a:xfrm>
-            <a:off x="640080" y="4636008"/>
+            <a:off x="640080" y="3721608"/>
             <a:ext cx="310896" cy="310896"/>
           </a:xfrm>
           <a:prstGeom prst="rect">
@@ -7625,8 +7625,8 @@
         </p:nvSpPr>
         <p:spPr>
           <a:xfrm>
-            <a:off x="1097280" y="4590288"/>
-            <a:ext cx="5212080" cy="713232"/>
+            <a:off x="1097280" y="3675888"/>
+            <a:ext cx="5212080" cy="484632"/>
           </a:xfrm>
           <a:prstGeom prst="rect">
             <a:avLst/>
@@ -7692,12 +7692,12 @@
         </p:nvSpPr>
         <p:spPr>
           <a:xfrm>
-            <a:off x="640080" y="5394960"/>
-            <a:ext cx="5669280" cy="914400"/>
+            <a:off x="6583680" y="1783080"/>
+            <a:ext cx="5029200" cy="2194560"/>
           </a:xfrm>
           <a:prstGeom prst="roundRect">
             <a:avLst>
-              <a:gd name="adj" fmla="val 9000"/>
+              <a:gd name="adj" fmla="val 3750"/>
             </a:avLst>
           </a:prstGeom>
           <a:solidFill>
@@ -7719,8 +7719,8 @@
         </p:nvSpPr>
         <p:spPr>
           <a:xfrm>
-            <a:off x="841248" y="5541264"/>
-            <a:ext cx="5266944" cy="329184"/>
+            <a:off x="6784848" y="1929384"/>
+            <a:ext cx="4626864" cy="329184"/>
           </a:xfrm>
           <a:prstGeom prst="rect">
             <a:avLst/>
@@ -7758,8 +7758,8 @@
         </p:nvSpPr>
         <p:spPr>
           <a:xfrm>
-            <a:off x="841248" y="5870448"/>
-            <a:ext cx="5266944" cy="310896"/>
+            <a:off x="6784848" y="2258568"/>
+            <a:ext cx="4626864" cy="1591056"/>
           </a:xfrm>
           <a:prstGeom prst="rect">
             <a:avLst/>
@@ -7778,7 +7778,7 @@
               <a:buNone/>
             </a:pPr>
             <a:r>
-              <a:rPr lang="en-US" sz="1200" dirty="0">
+              <a:rPr lang="en-US" sz="1300" dirty="0">
                 <a:solidFill>
                   <a:srgbClr val="E8EEF7"/>
                 </a:solidFill>
@@ -7786,9 +7786,38 @@
                 <a:ea typeface="Calibri" pitchFamily="34" charset="-122"/>
                 <a:cs typeface="Calibri" pitchFamily="34" charset="-120"/>
               </a:rPr>
-              <a:t>Editar, Redefinir senha e a chave Ativo — desativar impede o login sem apagar o histórico.</a:t>
-            </a:r>
-            <a:endParaRPr lang="en-US" sz="1200" dirty="0"/>
+              <a:t>Editar, Redefinir senha e a chave Ativo — desativar impede o login sem apagar o histórico do usuário.</a:t>
+            </a:r>
+            <a:endParaRPr lang="en-US" sz="1300" dirty="0"/>
+          </a:p>
+          <a:p>
+            <a:pPr indent="0" marL="0">
+              <a:lnSpc>
+                <a:spcPct val="112000"/>
+              </a:lnSpc>
+              <a:buNone/>
+            </a:pPr>
+            <a:endParaRPr lang="en-US" sz="1300" dirty="0"/>
+          </a:p>
+          <a:p>
+            <a:pPr indent="0" marL="0">
+              <a:lnSpc>
+                <a:spcPct val="112000"/>
+              </a:lnSpc>
+              <a:buNone/>
+            </a:pPr>
+            <a:r>
+              <a:rPr lang="en-US" sz="1300" dirty="0">
+                <a:solidFill>
+                  <a:srgbClr val="E8EEF7"/>
+                </a:solidFill>
+                <a:latin typeface="Calibri" pitchFamily="34" charset="0"/>
+                <a:ea typeface="Calibri" pitchFamily="34" charset="-122"/>
+                <a:cs typeface="Calibri" pitchFamily="34" charset="-120"/>
+              </a:rPr>
+              <a:t>A busca tem autocompletar com os nomes cadastrados.</a:t>
+            </a:r>
+            <a:endParaRPr lang="en-US" sz="1300" dirty="0"/>
           </a:p>
         </p:txBody>
       </p:sp>
@@ -7800,12 +7829,12 @@
         </p:nvSpPr>
         <p:spPr>
           <a:xfrm>
-            <a:off x="6583680" y="1645920"/>
-            <a:ext cx="5029200" cy="823866"/>
+            <a:off x="1879092" y="4343400"/>
+            <a:ext cx="8494776" cy="1874520"/>
           </a:xfrm>
           <a:prstGeom prst="roundRect">
             <a:avLst>
-              <a:gd name="adj" fmla="val 9989"/>
+              <a:gd name="adj" fmla="val 4390"/>
             </a:avLst>
           </a:prstGeom>
           <a:solidFill>
@@ -7835,8 +7864,8 @@
         </p:blipFill>
         <p:spPr>
           <a:xfrm>
-            <a:off x="6693408" y="1755648"/>
-            <a:ext cx="4809744" cy="604410"/>
+            <a:off x="1988820" y="4453128"/>
+            <a:ext cx="8275320" cy="1655064"/>
           </a:xfrm>
           <a:prstGeom prst="rect">
             <a:avLst/>

</xml_diff>